<commit_message>
feat(cv): curriculum mejorado - SVGs oficiales de lenguajes, modal descarga multi-formato (pdf/pptx/zip/png), CV custom destacado + resumen validado, iconos consistentes, navbar ciszu Courses visible, About fuera de Information, pantalla completa responsiva
</commit_message>
<xml_diff>
--- a/shared/docs/cv/CV-Curriculum-Custom-Francisco_Garcia_Menolascina_Antonio-2026-Oficial.pptx
+++ b/shared/docs/cv/CV-Curriculum-Custom-Francisco_Garcia_Menolascina_Antonio-2026-Oficial.pptx
@@ -4612,8 +4612,8 @@
         </p:nvSpPr>
         <p:spPr>
           <a:xfrm rot="0">
-            <a:off x="783070" y="3454816"/>
-            <a:ext cx="2854077" cy="368300"/>
+            <a:off x="1003478" y="3454816"/>
+            <a:ext cx="2091184" cy="368300"/>
           </a:xfrm>
           <a:prstGeom prst="rect">
             <a:avLst/>
@@ -4640,7 +4640,7 @@
                 <a:cs typeface="Poppins Medium"/>
                 <a:sym typeface="Poppins Medium"/>
               </a:rPr>
-              <a:t>BREVEPERFIL PERSONAL</a:t>
+              <a:t>PERFIL PERSONAL</a:t>
             </a:r>
           </a:p>
         </p:txBody>
@@ -9763,8 +9763,8 @@
         </p:nvSpPr>
         <p:spPr>
           <a:xfrm rot="0">
-            <a:off x="913792" y="1150155"/>
-            <a:ext cx="2572833" cy="238336"/>
+            <a:off x="952487" y="1150155"/>
+            <a:ext cx="2572833" cy="119803"/>
           </a:xfrm>
           <a:prstGeom prst="rect">
             <a:avLst/>
@@ -9776,15 +9776,13 @@
           </a:bodyPr>
           <a:lstStyle/>
           <a:p>
-            <a:pPr algn="l" marL="151130" indent="-75565" lvl="1">
+            <a:pPr algn="l">
               <a:lnSpc>
                 <a:spcPts val="979"/>
               </a:lnSpc>
               <a:spcBef>
                 <a:spcPct val="0"/>
               </a:spcBef>
-              <a:buFont typeface="Arial"/>
-              <a:buChar char="•"/>
             </a:pPr>
             <a:r>
               <a:rPr lang="en-US" b="true" sz="699">

</xml_diff>